<commit_message>
Marketing docs and license agreement updates
</commit_message>
<xml_diff>
--- a/docs/GeoNap Presentations/GeoNap_Marketing_Deck.pptx
+++ b/docs/GeoNap Presentations/GeoNap_Marketing_Deck.pptx
@@ -318,7 +318,7 @@
           <a:p>
             <a:fld id="{5BCAD085-E8A6-8845-BD4E-CB4CCA059FC4}" type="datetimeFigureOut">
               <a:rPr lang="en-US" smtClean="0"/>
-              <a:t>7/3/26</a:t>
+              <a:t>7/10/26</a:t>
             </a:fld>
             <a:endParaRPr lang="en-US"/>
           </a:p>
@@ -486,7 +486,7 @@
           <a:p>
             <a:fld id="{5BCAD085-E8A6-8845-BD4E-CB4CCA059FC4}" type="datetimeFigureOut">
               <a:rPr lang="en-US" smtClean="0"/>
-              <a:t>7/3/26</a:t>
+              <a:t>7/10/26</a:t>
             </a:fld>
             <a:endParaRPr lang="en-US"/>
           </a:p>
@@ -664,7 +664,7 @@
           <a:p>
             <a:fld id="{5BCAD085-E8A6-8845-BD4E-CB4CCA059FC4}" type="datetimeFigureOut">
               <a:rPr lang="en-US" smtClean="0"/>
-              <a:t>7/3/26</a:t>
+              <a:t>7/10/26</a:t>
             </a:fld>
             <a:endParaRPr lang="en-US"/>
           </a:p>
@@ -832,7 +832,7 @@
           <a:p>
             <a:fld id="{5BCAD085-E8A6-8845-BD4E-CB4CCA059FC4}" type="datetimeFigureOut">
               <a:rPr lang="en-US" smtClean="0"/>
-              <a:t>7/3/26</a:t>
+              <a:t>7/10/26</a:t>
             </a:fld>
             <a:endParaRPr lang="en-US"/>
           </a:p>
@@ -1077,7 +1077,7 @@
           <a:p>
             <a:fld id="{5BCAD085-E8A6-8845-BD4E-CB4CCA059FC4}" type="datetimeFigureOut">
               <a:rPr lang="en-US" smtClean="0"/>
-              <a:t>7/3/26</a:t>
+              <a:t>7/10/26</a:t>
             </a:fld>
             <a:endParaRPr lang="en-US"/>
           </a:p>
@@ -1362,7 +1362,7 @@
           <a:p>
             <a:fld id="{5BCAD085-E8A6-8845-BD4E-CB4CCA059FC4}" type="datetimeFigureOut">
               <a:rPr lang="en-US" smtClean="0"/>
-              <a:t>7/3/26</a:t>
+              <a:t>7/10/26</a:t>
             </a:fld>
             <a:endParaRPr lang="en-US"/>
           </a:p>
@@ -1781,7 +1781,7 @@
           <a:p>
             <a:fld id="{5BCAD085-E8A6-8845-BD4E-CB4CCA059FC4}" type="datetimeFigureOut">
               <a:rPr lang="en-US" smtClean="0"/>
-              <a:t>7/3/26</a:t>
+              <a:t>7/10/26</a:t>
             </a:fld>
             <a:endParaRPr lang="en-US"/>
           </a:p>
@@ -1898,7 +1898,7 @@
           <a:p>
             <a:fld id="{5BCAD085-E8A6-8845-BD4E-CB4CCA059FC4}" type="datetimeFigureOut">
               <a:rPr lang="en-US" smtClean="0"/>
-              <a:t>7/3/26</a:t>
+              <a:t>7/10/26</a:t>
             </a:fld>
             <a:endParaRPr lang="en-US"/>
           </a:p>
@@ -1993,7 +1993,7 @@
           <a:p>
             <a:fld id="{5BCAD085-E8A6-8845-BD4E-CB4CCA059FC4}" type="datetimeFigureOut">
               <a:rPr lang="en-US" smtClean="0"/>
-              <a:t>7/3/26</a:t>
+              <a:t>7/10/26</a:t>
             </a:fld>
             <a:endParaRPr lang="en-US"/>
           </a:p>
@@ -2268,7 +2268,7 @@
           <a:p>
             <a:fld id="{5BCAD085-E8A6-8845-BD4E-CB4CCA059FC4}" type="datetimeFigureOut">
               <a:rPr lang="en-US" smtClean="0"/>
-              <a:t>7/3/26</a:t>
+              <a:t>7/10/26</a:t>
             </a:fld>
             <a:endParaRPr lang="en-US"/>
           </a:p>
@@ -2520,7 +2520,7 @@
           <a:p>
             <a:fld id="{5BCAD085-E8A6-8845-BD4E-CB4CCA059FC4}" type="datetimeFigureOut">
               <a:rPr lang="en-US" smtClean="0"/>
-              <a:t>7/3/26</a:t>
+              <a:t>7/10/26</a:t>
             </a:fld>
             <a:endParaRPr lang="en-US"/>
           </a:p>
@@ -2731,7 +2731,7 @@
           <a:p>
             <a:fld id="{5BCAD085-E8A6-8845-BD4E-CB4CCA059FC4}" type="datetimeFigureOut">
               <a:rPr lang="en-US" smtClean="0"/>
-              <a:t>7/3/26</a:t>
+              <a:t>7/10/26</a:t>
             </a:fld>
             <a:endParaRPr lang="en-US"/>
           </a:p>
@@ -3545,7 +3545,7 @@
               </a:lnSpc>
             </a:pPr>
             <a:r>
-              <a:rPr sz="4400" b="1" i="0">
+              <a:rPr sz="4400" b="1" i="0" dirty="0">
                 <a:solidFill>
                   <a:srgbClr val="FFFFFF"/>
                 </a:solidFill>
@@ -3584,7 +3584,7 @@
               </a:lnSpc>
             </a:pPr>
             <a:r>
-              <a:rPr sz="1700" b="0" i="0">
+              <a:rPr sz="1700" b="0" i="0" dirty="0">
                 <a:solidFill>
                   <a:srgbClr val="B9C6CE"/>
                 </a:solidFill>
@@ -3672,7 +3672,25 @@
                 </a:solidFill>
                 <a:latin typeface="Calibri"/>
               </a:rPr>
-              <a:t>For Commuters, Travelers &amp; Anyone Who Naps On the Move</a:t>
+              <a:t>For Commuters, Travelers</a:t>
+            </a:r>
+            <a:r>
+              <a:rPr lang="en-US" sz="1150" b="1" i="0" dirty="0">
+                <a:solidFill>
+                  <a:srgbClr val="F5C842"/>
+                </a:solidFill>
+                <a:latin typeface="Calibri"/>
+              </a:rPr>
+              <a:t> &amp;</a:t>
+            </a:r>
+            <a:r>
+              <a:rPr sz="1150" b="1" i="0" dirty="0">
+                <a:solidFill>
+                  <a:srgbClr val="F5C842"/>
+                </a:solidFill>
+                <a:latin typeface="Calibri"/>
+              </a:rPr>
+              <a:t> Anyone Who Naps On the Move</a:t>
             </a:r>
           </a:p>
         </p:txBody>
@@ -3789,7 +3807,7 @@
                 </a:solidFill>
                 <a:latin typeface="Calibri"/>
               </a:rPr>
-              <a:t>1.117-20260703</a:t>
+              <a:t>1.130-20260709</a:t>
             </a:r>
             <a:endParaRPr sz="1150" b="1" i="0" dirty="0">
               <a:solidFill>
@@ -7818,8 +7836,8 @@
         </p:nvSpPr>
         <p:spPr>
           <a:xfrm>
-            <a:off x="4358487" y="4434840"/>
-            <a:ext cx="3474720" cy="566928"/>
+            <a:off x="4358487" y="4610582"/>
+            <a:ext cx="3474720" cy="215444"/>
           </a:xfrm>
           <a:prstGeom prst="rect">
             <a:avLst/>
@@ -7834,27 +7852,142 @@
           <a:p>
             <a:pPr algn="ctr"/>
             <a:r>
-              <a:rPr sz="1400" b="1" i="0" dirty="0">
+              <a:rPr lang="en-US" sz="1400" b="1" i="0" dirty="0">
                 <a:solidFill>
                   <a:srgbClr val="FFFFFF"/>
                 </a:solidFill>
                 <a:latin typeface="Calibri"/>
-              </a:rPr>
-              <a:t>Download </a:t>
-            </a:r>
-            <a:r>
-              <a:rPr sz="1400" b="1" i="0" dirty="0" err="1">
+                <a:hlinkClick r:id="rId3"/>
+              </a:rPr>
+              <a:t>Download GeoNap (iOS device)</a:t>
+            </a:r>
+            <a:r>
+              <a:rPr lang="en-US" sz="1400" b="1" i="0" dirty="0">
                 <a:solidFill>
                   <a:srgbClr val="FFFFFF"/>
                 </a:solidFill>
                 <a:latin typeface="Calibri"/>
               </a:rPr>
-              <a:t>GeoNap</a:t>
+              <a:t> **</a:t>
             </a:r>
             <a:endParaRPr sz="1400" b="1" i="0" dirty="0">
               <a:solidFill>
                 <a:srgbClr val="FFFFFF"/>
               </a:solidFill>
+              <a:latin typeface="Calibri"/>
+            </a:endParaRPr>
+          </a:p>
+        </p:txBody>
+      </p:sp>
+      <p:sp>
+        <p:nvSpPr>
+          <p:cNvPr id="7" name="TextBox 6">
+            <a:extLst>
+              <a:ext uri="{FF2B5EF4-FFF2-40B4-BE49-F238E27FC236}">
+                <a16:creationId xmlns:a16="http://schemas.microsoft.com/office/drawing/2014/main" id="{27815AFA-D1BA-67B5-F575-FB3E5A233B36}"/>
+              </a:ext>
+            </a:extLst>
+          </p:cNvPr>
+          <p:cNvSpPr txBox="1"/>
+          <p:nvPr/>
+        </p:nvSpPr>
+        <p:spPr>
+          <a:xfrm>
+            <a:off x="6229349" y="5570220"/>
+            <a:ext cx="5702139" cy="998350"/>
+          </a:xfrm>
+          <a:prstGeom prst="rect">
+            <a:avLst/>
+          </a:prstGeom>
+          <a:gradFill flip="none" rotWithShape="1">
+            <a:gsLst>
+              <a:gs pos="0">
+                <a:schemeClr val="accent1">
+                  <a:lumMod val="5000"/>
+                  <a:lumOff val="95000"/>
+                </a:schemeClr>
+              </a:gs>
+              <a:gs pos="74000">
+                <a:schemeClr val="accent1">
+                  <a:lumMod val="45000"/>
+                  <a:lumOff val="55000"/>
+                </a:schemeClr>
+              </a:gs>
+              <a:gs pos="83000">
+                <a:schemeClr val="accent1">
+                  <a:lumMod val="45000"/>
+                  <a:lumOff val="55000"/>
+                </a:schemeClr>
+              </a:gs>
+              <a:gs pos="100000">
+                <a:schemeClr val="accent1">
+                  <a:lumMod val="30000"/>
+                  <a:lumOff val="70000"/>
+                </a:schemeClr>
+              </a:gs>
+            </a:gsLst>
+            <a:lin ang="5400000" scaled="1"/>
+            <a:tileRect/>
+          </a:gradFill>
+        </p:spPr>
+        <p:txBody>
+          <a:bodyPr wrap="square" lIns="91440" tIns="91440" rIns="91440" bIns="91440" anchor="t">
+            <a:spAutoFit/>
+          </a:bodyPr>
+          <a:lstStyle/>
+          <a:p>
+            <a:pPr algn="r">
+              <a:lnSpc>
+                <a:spcPct val="120000"/>
+              </a:lnSpc>
+            </a:pPr>
+            <a:r>
+              <a:rPr lang="en-US" sz="1700" b="0" i="0" dirty="0">
+                <a:latin typeface="Calibri"/>
+              </a:rPr>
+              <a:t>** </a:t>
+            </a:r>
+            <a:r>
+              <a:rPr lang="en-US" sz="1400" b="0" i="0" dirty="0" err="1">
+                <a:latin typeface="Calibri"/>
+              </a:rPr>
+              <a:t>GeoNap</a:t>
+            </a:r>
+            <a:r>
+              <a:rPr lang="en-US" sz="1400" b="0" i="0" dirty="0">
+                <a:latin typeface="Calibri"/>
+              </a:rPr>
+              <a:t> is available in test mode only. As such, Apple requires installation of an app </a:t>
+            </a:r>
+            <a:r>
+              <a:rPr lang="en-US" sz="1400" b="0" i="0" dirty="0">
+                <a:solidFill>
+                  <a:srgbClr val="0070C0"/>
+                </a:solidFill>
+                <a:latin typeface="Calibri"/>
+                <a:hlinkClick r:id="rId4"/>
+              </a:rPr>
+              <a:t>“TestFlight” </a:t>
+            </a:r>
+            <a:r>
+              <a:rPr lang="en-US" sz="1400" b="0" i="0" dirty="0">
+                <a:latin typeface="Calibri"/>
+              </a:rPr>
+              <a:t>on their local iOS device. </a:t>
+            </a:r>
+            <a:r>
+              <a:rPr lang="en-US" sz="1400" b="0" i="0" dirty="0" err="1">
+                <a:latin typeface="Calibri"/>
+              </a:rPr>
+              <a:t>GeoNap</a:t>
+            </a:r>
+            <a:r>
+              <a:rPr lang="en-US" sz="1400" b="0" i="0" dirty="0">
+                <a:latin typeface="Calibri"/>
+              </a:rPr>
+              <a:t> installation, upgrades and feedback is done using the TestFlight application.</a:t>
+            </a:r>
+            <a:endParaRPr sz="1700" b="0" i="0" dirty="0">
               <a:latin typeface="Calibri"/>
             </a:endParaRPr>
           </a:p>

</xml_diff>

<commit_message>
* Updated the privacy policy with accurate disclosures for contacts and Watch data sharing (all 13 languages). * Ensure Apple Watch debug and paring data is routed through debug log to assist in field resolutions * Update Marking pptx with Privacy updates and add pricey summary slide * Add Apple Watch integration CI test suite
</commit_message>
<xml_diff>
--- a/docs/GeoNap Presentations/GeoNap_Marketing_Deck.pptx
+++ b/docs/GeoNap Presentations/GeoNap_Marketing_Deck.pptx
@@ -20,9 +20,10 @@
     <p:sldId id="268" r:id="rId14"/>
     <p:sldId id="269" r:id="rId15"/>
     <p:sldId id="270" r:id="rId16"/>
-    <p:sldId id="271" r:id="rId17"/>
-    <p:sldId id="273" r:id="rId18"/>
-    <p:sldId id="272" r:id="rId19"/>
+    <p:sldId id="274" r:id="rId17"/>
+    <p:sldId id="271" r:id="rId18"/>
+    <p:sldId id="273" r:id="rId19"/>
+    <p:sldId id="272" r:id="rId20"/>
   </p:sldIdLst>
   <p:sldSz cx="12192000" cy="6858000"/>
   <p:notesSz cx="6858000" cy="9144000"/>
@@ -7093,6 +7094,950 @@
 </file>
 
 <file path=ppt/slides/slide16.xml><?xml version="1.0" encoding="utf-8"?>
+<p:sld xmlns:a="http://schemas.openxmlformats.org/drawingml/2006/main" xmlns:r="http://schemas.openxmlformats.org/officeDocument/2006/relationships" xmlns:p="http://schemas.openxmlformats.org/presentationml/2006/main">
+  <p:cSld>
+    <p:bg>
+      <p:bgPr>
+        <a:solidFill>
+          <a:srgbClr val="1A3A52"/>
+        </a:solidFill>
+        <a:effectLst/>
+      </p:bgPr>
+    </p:bg>
+    <p:spTree>
+      <p:nvGrpSpPr>
+        <p:cNvPr id="1" name=""/>
+        <p:cNvGrpSpPr/>
+        <p:nvPr/>
+      </p:nvGrpSpPr>
+      <p:grpSpPr>
+        <a:xfrm>
+          <a:off x="0" y="0"/>
+          <a:ext cx="0" cy="0"/>
+          <a:chOff x="0" y="0"/>
+          <a:chExt cx="0" cy="0"/>
+        </a:xfrm>
+      </p:grpSpPr>
+      <p:sp>
+        <p:nvSpPr>
+          <p:cNvPr id="3" name="TextBox 1"/>
+          <p:cNvSpPr txBox="1"/>
+          <p:nvPr/>
+        </p:nvSpPr>
+        <p:spPr>
+          <a:xfrm>
+            <a:off x="548640" y="457200"/>
+            <a:ext cx="7315200" cy="320040"/>
+          </a:xfrm>
+          <a:prstGeom prst="rect">
+            <a:avLst/>
+          </a:prstGeom>
+          <a:noFill/>
+        </p:spPr>
+        <p:txBody>
+          <a:bodyPr wrap="square" lIns="0" tIns="0" rIns="0" bIns="0" anchor="t">
+            <a:spAutoFit/>
+          </a:bodyPr>
+          <a:lstStyle/>
+          <a:p>
+            <a:pPr algn="l"/>
+            <a:r>
+              <a:rPr sz="1300" b="1" i="0" spc="160">
+                <a:solidFill>
+                  <a:srgbClr val="F5C842"/>
+                </a:solidFill>
+                <a:latin typeface="Calibri"/>
+              </a:rPr>
+              <a:t>YOUR DATA, YOUR CONTROL</a:t>
+            </a:r>
+          </a:p>
+        </p:txBody>
+      </p:sp>
+      <p:sp>
+        <p:nvSpPr>
+          <p:cNvPr id="4" name="TextBox 2"/>
+          <p:cNvSpPr txBox="1"/>
+          <p:nvPr/>
+        </p:nvSpPr>
+        <p:spPr>
+          <a:xfrm>
+            <a:off x="548640" y="749808"/>
+            <a:ext cx="9997135" cy="822960"/>
+          </a:xfrm>
+          <a:prstGeom prst="rect">
+            <a:avLst/>
+          </a:prstGeom>
+          <a:noFill/>
+        </p:spPr>
+        <p:txBody>
+          <a:bodyPr wrap="square" lIns="0" tIns="0" rIns="0" bIns="0" anchor="t">
+            <a:spAutoFit/>
+          </a:bodyPr>
+          <a:lstStyle/>
+          <a:p>
+            <a:pPr algn="l">
+              <a:lnSpc>
+                <a:spcPct val="102000"/>
+              </a:lnSpc>
+            </a:pPr>
+            <a:r>
+              <a:rPr sz="3000" b="1" i="0">
+                <a:solidFill>
+                  <a:srgbClr val="FFFFFF"/>
+                </a:solidFill>
+                <a:latin typeface="Cambria"/>
+              </a:rPr>
+              <a:t>Privacy at a Glance</a:t>
+            </a:r>
+          </a:p>
+        </p:txBody>
+      </p:sp>
+      <p:sp>
+        <p:nvSpPr>
+          <p:cNvPr id="5" name="Rounded Rectangle"/>
+          <p:cNvSpPr/>
+          <p:nvPr/>
+        </p:nvSpPr>
+        <p:spPr>
+          <a:xfrm>
+            <a:off x="548640" y="1874519"/>
+            <a:ext cx="5364327" cy="2148840"/>
+          </a:xfrm>
+          <a:prstGeom prst="roundRect">
+            <a:avLst>
+              <a:gd name="adj" fmla="val 7000"/>
+            </a:avLst>
+          </a:prstGeom>
+          <a:solidFill>
+            <a:srgbClr val="24455F"/>
+          </a:solidFill>
+          <a:ln>
+            <a:noFill/>
+          </a:ln>
+          <a:effectLst/>
+        </p:spPr>
+        <p:style>
+          <a:lnRef idx="1">
+            <a:schemeClr val="accent1"/>
+          </a:lnRef>
+          <a:fillRef idx="3">
+            <a:schemeClr val="accent1"/>
+          </a:fillRef>
+          <a:effectRef idx="2">
+            <a:schemeClr val="accent1"/>
+          </a:effectRef>
+          <a:fontRef idx="minor">
+            <a:schemeClr val="lt1"/>
+          </a:fontRef>
+        </p:style>
+        <p:txBody>
+          <a:bodyPr rtlCol="0" anchor="ctr"/>
+          <a:lstStyle/>
+          <a:p>
+            <a:pPr algn="ctr"/>
+            <a:endParaRPr/>
+          </a:p>
+        </p:txBody>
+      </p:sp>
+      <p:sp>
+        <p:nvSpPr>
+          <p:cNvPr id="6" name="Oval"/>
+          <p:cNvSpPr/>
+          <p:nvPr/>
+        </p:nvSpPr>
+        <p:spPr>
+          <a:xfrm>
+            <a:off x="822960" y="2619756"/>
+            <a:ext cx="658368" cy="658368"/>
+          </a:xfrm>
+          <a:prstGeom prst="ellipse">
+            <a:avLst/>
+          </a:prstGeom>
+          <a:solidFill>
+            <a:srgbClr val="0F2836"/>
+          </a:solidFill>
+          <a:ln>
+            <a:noFill/>
+          </a:ln>
+          <a:effectLst/>
+        </p:spPr>
+        <p:style>
+          <a:lnRef idx="1">
+            <a:schemeClr val="accent1"/>
+          </a:lnRef>
+          <a:fillRef idx="3">
+            <a:schemeClr val="accent1"/>
+          </a:fillRef>
+          <a:effectRef idx="2">
+            <a:schemeClr val="accent1"/>
+          </a:effectRef>
+          <a:fontRef idx="minor">
+            <a:schemeClr val="lt1"/>
+          </a:fontRef>
+        </p:style>
+        <p:txBody>
+          <a:bodyPr rtlCol="0" anchor="ctr"/>
+          <a:lstStyle/>
+          <a:p>
+            <a:pPr algn="ctr"/>
+            <a:endParaRPr/>
+          </a:p>
+        </p:txBody>
+      </p:sp>
+      <p:pic>
+        <p:nvPicPr>
+          <p:cNvPr id="7" name="Picture" descr="privacy_icon.png"/>
+          <p:cNvPicPr>
+            <a:picLocks noChangeAspect="1"/>
+          </p:cNvPicPr>
+          <p:nvPr/>
+        </p:nvPicPr>
+        <p:blipFill>
+          <a:blip r:embed="rId2"/>
+          <a:stretch>
+            <a:fillRect/>
+          </a:stretch>
+        </p:blipFill>
+        <p:spPr>
+          <a:xfrm>
+            <a:off x="980968" y="2777764"/>
+            <a:ext cx="342351" cy="342351"/>
+          </a:xfrm>
+          <a:prstGeom prst="rect">
+            <a:avLst/>
+          </a:prstGeom>
+        </p:spPr>
+      </p:pic>
+      <p:sp>
+        <p:nvSpPr>
+          <p:cNvPr id="8" name="TextBox Header"/>
+          <p:cNvSpPr txBox="1"/>
+          <p:nvPr/>
+        </p:nvSpPr>
+        <p:spPr>
+          <a:xfrm>
+            <a:off x="1645919" y="2075688"/>
+            <a:ext cx="4038447" cy="365760"/>
+          </a:xfrm>
+          <a:prstGeom prst="rect">
+            <a:avLst/>
+          </a:prstGeom>
+          <a:noFill/>
+        </p:spPr>
+        <p:txBody>
+          <a:bodyPr wrap="square" lIns="0" tIns="0" rIns="0" bIns="0" anchor="t">
+            <a:spAutoFit/>
+          </a:bodyPr>
+          <a:lstStyle/>
+          <a:p>
+            <a:pPr algn="l"/>
+            <a:r>
+              <a:rPr sz="1550" b="1" i="0">
+                <a:solidFill>
+                  <a:srgbClr val="FFFFFF"/>
+                </a:solidFill>
+                <a:latin typeface="Cambria"/>
+              </a:rPr>
+              <a:t>Location</a:t>
+            </a:r>
+          </a:p>
+        </p:txBody>
+      </p:sp>
+      <p:sp>
+        <p:nvSpPr>
+          <p:cNvPr id="9" name="TextBox Body"/>
+          <p:cNvSpPr txBox="1"/>
+          <p:nvPr/>
+        </p:nvSpPr>
+        <p:spPr>
+          <a:xfrm>
+            <a:off x="1645919" y="2441448"/>
+            <a:ext cx="4038447" cy="1417320"/>
+          </a:xfrm>
+          <a:prstGeom prst="rect">
+            <a:avLst/>
+          </a:prstGeom>
+          <a:noFill/>
+        </p:spPr>
+        <p:txBody>
+          <a:bodyPr wrap="square" lIns="0" tIns="0" rIns="0" bIns="0" anchor="t">
+            <a:spAutoFit/>
+          </a:bodyPr>
+          <a:lstStyle/>
+          <a:p>
+            <a:pPr algn="l">
+              <a:lnSpc>
+                <a:spcPct val="118000"/>
+              </a:lnSpc>
+            </a:pPr>
+            <a:r>
+              <a:rPr sz="1200" b="0" i="0">
+                <a:solidFill>
+                  <a:srgbClr val="B9C6CE"/>
+                </a:solidFill>
+                <a:latin typeface="Calibri"/>
+              </a:rPr>
+              <a:t>Processed entirely on your device — never sent to any server I operate, and kept only as long as needed to trigger your alarm.</a:t>
+            </a:r>
+          </a:p>
+        </p:txBody>
+      </p:sp>
+      <p:sp>
+        <p:nvSpPr>
+          <p:cNvPr id="10" name="Rounded Rectangle"/>
+          <p:cNvSpPr/>
+          <p:nvPr/>
+        </p:nvSpPr>
+        <p:spPr>
+          <a:xfrm>
+            <a:off x="6278727" y="1874519"/>
+            <a:ext cx="5364327" cy="2148840"/>
+          </a:xfrm>
+          <a:prstGeom prst="roundRect">
+            <a:avLst>
+              <a:gd name="adj" fmla="val 7000"/>
+            </a:avLst>
+          </a:prstGeom>
+          <a:solidFill>
+            <a:srgbClr val="24455F"/>
+          </a:solidFill>
+          <a:ln>
+            <a:noFill/>
+          </a:ln>
+          <a:effectLst/>
+        </p:spPr>
+        <p:style>
+          <a:lnRef idx="1">
+            <a:schemeClr val="accent1"/>
+          </a:lnRef>
+          <a:fillRef idx="3">
+            <a:schemeClr val="accent1"/>
+          </a:fillRef>
+          <a:effectRef idx="2">
+            <a:schemeClr val="accent1"/>
+          </a:effectRef>
+          <a:fontRef idx="minor">
+            <a:schemeClr val="lt1"/>
+          </a:fontRef>
+        </p:style>
+        <p:txBody>
+          <a:bodyPr rtlCol="0" anchor="ctr"/>
+          <a:lstStyle/>
+          <a:p>
+            <a:pPr algn="ctr"/>
+            <a:endParaRPr/>
+          </a:p>
+        </p:txBody>
+      </p:sp>
+      <p:sp>
+        <p:nvSpPr>
+          <p:cNvPr id="11" name="Oval"/>
+          <p:cNvSpPr/>
+          <p:nvPr/>
+        </p:nvSpPr>
+        <p:spPr>
+          <a:xfrm>
+            <a:off x="6553047" y="2619756"/>
+            <a:ext cx="658368" cy="658368"/>
+          </a:xfrm>
+          <a:prstGeom prst="ellipse">
+            <a:avLst/>
+          </a:prstGeom>
+          <a:solidFill>
+            <a:srgbClr val="0F2836"/>
+          </a:solidFill>
+          <a:ln>
+            <a:noFill/>
+          </a:ln>
+          <a:effectLst/>
+        </p:spPr>
+        <p:style>
+          <a:lnRef idx="1">
+            <a:schemeClr val="accent1"/>
+          </a:lnRef>
+          <a:fillRef idx="3">
+            <a:schemeClr val="accent1"/>
+          </a:fillRef>
+          <a:effectRef idx="2">
+            <a:schemeClr val="accent1"/>
+          </a:effectRef>
+          <a:fontRef idx="minor">
+            <a:schemeClr val="lt1"/>
+          </a:fontRef>
+        </p:style>
+        <p:txBody>
+          <a:bodyPr rtlCol="0" anchor="ctr"/>
+          <a:lstStyle/>
+          <a:p>
+            <a:pPr algn="ctr"/>
+            <a:endParaRPr/>
+          </a:p>
+        </p:txBody>
+      </p:sp>
+      <p:pic>
+        <p:nvPicPr>
+          <p:cNvPr id="12" name="Picture" descr="privacy_icon.png"/>
+          <p:cNvPicPr>
+            <a:picLocks noChangeAspect="1"/>
+          </p:cNvPicPr>
+          <p:nvPr/>
+        </p:nvPicPr>
+        <p:blipFill>
+          <a:blip r:embed="rId3"/>
+          <a:stretch>
+            <a:fillRect/>
+          </a:stretch>
+        </p:blipFill>
+        <p:spPr>
+          <a:xfrm>
+            <a:off x="6711055" y="2777764"/>
+            <a:ext cx="342351" cy="342351"/>
+          </a:xfrm>
+          <a:prstGeom prst="rect">
+            <a:avLst/>
+          </a:prstGeom>
+        </p:spPr>
+      </p:pic>
+      <p:sp>
+        <p:nvSpPr>
+          <p:cNvPr id="13" name="TextBox Header"/>
+          <p:cNvSpPr txBox="1"/>
+          <p:nvPr/>
+        </p:nvSpPr>
+        <p:spPr>
+          <a:xfrm>
+            <a:off x="7376006" y="2075688"/>
+            <a:ext cx="4038447" cy="365760"/>
+          </a:xfrm>
+          <a:prstGeom prst="rect">
+            <a:avLst/>
+          </a:prstGeom>
+          <a:noFill/>
+        </p:spPr>
+        <p:txBody>
+          <a:bodyPr wrap="square" lIns="0" tIns="0" rIns="0" bIns="0" anchor="t">
+            <a:spAutoFit/>
+          </a:bodyPr>
+          <a:lstStyle/>
+          <a:p>
+            <a:pPr algn="l"/>
+            <a:r>
+              <a:rPr sz="1550" b="1" i="0">
+                <a:solidFill>
+                  <a:srgbClr val="FFFFFF"/>
+                </a:solidFill>
+                <a:latin typeface="Cambria"/>
+              </a:rPr>
+              <a:t>Auto-Notify Contacts</a:t>
+            </a:r>
+          </a:p>
+        </p:txBody>
+      </p:sp>
+      <p:sp>
+        <p:nvSpPr>
+          <p:cNvPr id="14" name="TextBox Body"/>
+          <p:cNvSpPr txBox="1"/>
+          <p:nvPr/>
+        </p:nvSpPr>
+        <p:spPr>
+          <a:xfrm>
+            <a:off x="7376006" y="2441448"/>
+            <a:ext cx="4038447" cy="1417320"/>
+          </a:xfrm>
+          <a:prstGeom prst="rect">
+            <a:avLst/>
+          </a:prstGeom>
+          <a:noFill/>
+        </p:spPr>
+        <p:txBody>
+          <a:bodyPr wrap="square" lIns="0" tIns="0" rIns="0" bIns="0" anchor="t">
+            <a:spAutoFit/>
+          </a:bodyPr>
+          <a:lstStyle/>
+          <a:p>
+            <a:pPr algn="l">
+              <a:lnSpc>
+                <a:spcPct val="118000"/>
+              </a:lnSpc>
+            </a:pPr>
+            <a:r>
+              <a:rPr sz="1200" b="0" i="0">
+                <a:solidFill>
+                  <a:srgbClr val="B9C6CE"/>
+                </a:solidFill>
+                <a:latin typeface="Calibri"/>
+              </a:rPr>
+              <a:t>Only the contact(s) you pick via Apple’s contact picker — just a name and phone number or email. No bulk access to your address book.</a:t>
+            </a:r>
+          </a:p>
+        </p:txBody>
+      </p:sp>
+      <p:sp>
+        <p:nvSpPr>
+          <p:cNvPr id="15" name="Rounded Rectangle"/>
+          <p:cNvSpPr/>
+          <p:nvPr/>
+        </p:nvSpPr>
+        <p:spPr>
+          <a:xfrm>
+            <a:off x="548640" y="4343400"/>
+            <a:ext cx="5364327" cy="2148840"/>
+          </a:xfrm>
+          <a:prstGeom prst="roundRect">
+            <a:avLst>
+              <a:gd name="adj" fmla="val 7000"/>
+            </a:avLst>
+          </a:prstGeom>
+          <a:solidFill>
+            <a:srgbClr val="24455F"/>
+          </a:solidFill>
+          <a:ln>
+            <a:noFill/>
+          </a:ln>
+          <a:effectLst/>
+        </p:spPr>
+        <p:style>
+          <a:lnRef idx="1">
+            <a:schemeClr val="accent1"/>
+          </a:lnRef>
+          <a:fillRef idx="3">
+            <a:schemeClr val="accent1"/>
+          </a:fillRef>
+          <a:effectRef idx="2">
+            <a:schemeClr val="accent1"/>
+          </a:effectRef>
+          <a:fontRef idx="minor">
+            <a:schemeClr val="lt1"/>
+          </a:fontRef>
+        </p:style>
+        <p:txBody>
+          <a:bodyPr rtlCol="0" anchor="ctr"/>
+          <a:lstStyle/>
+          <a:p>
+            <a:pPr algn="ctr"/>
+            <a:endParaRPr/>
+          </a:p>
+        </p:txBody>
+      </p:sp>
+      <p:sp>
+        <p:nvSpPr>
+          <p:cNvPr id="16" name="Oval"/>
+          <p:cNvSpPr/>
+          <p:nvPr/>
+        </p:nvSpPr>
+        <p:spPr>
+          <a:xfrm>
+            <a:off x="822960" y="5088637"/>
+            <a:ext cx="658368" cy="658368"/>
+          </a:xfrm>
+          <a:prstGeom prst="ellipse">
+            <a:avLst/>
+          </a:prstGeom>
+          <a:solidFill>
+            <a:srgbClr val="0F2836"/>
+          </a:solidFill>
+          <a:ln>
+            <a:noFill/>
+          </a:ln>
+          <a:effectLst/>
+        </p:spPr>
+        <p:style>
+          <a:lnRef idx="1">
+            <a:schemeClr val="accent1"/>
+          </a:lnRef>
+          <a:fillRef idx="3">
+            <a:schemeClr val="accent1"/>
+          </a:fillRef>
+          <a:effectRef idx="2">
+            <a:schemeClr val="accent1"/>
+          </a:effectRef>
+          <a:fontRef idx="minor">
+            <a:schemeClr val="lt1"/>
+          </a:fontRef>
+        </p:style>
+        <p:txBody>
+          <a:bodyPr rtlCol="0" anchor="ctr"/>
+          <a:lstStyle/>
+          <a:p>
+            <a:pPr algn="ctr"/>
+            <a:endParaRPr/>
+          </a:p>
+        </p:txBody>
+      </p:sp>
+      <p:pic>
+        <p:nvPicPr>
+          <p:cNvPr id="17" name="Picture" descr="privacy_icon.png"/>
+          <p:cNvPicPr>
+            <a:picLocks noChangeAspect="1"/>
+          </p:cNvPicPr>
+          <p:nvPr/>
+        </p:nvPicPr>
+        <p:blipFill>
+          <a:blip r:embed="rId4"/>
+          <a:stretch>
+            <a:fillRect/>
+          </a:stretch>
+        </p:blipFill>
+        <p:spPr>
+          <a:xfrm>
+            <a:off x="980968" y="5246645"/>
+            <a:ext cx="342351" cy="342351"/>
+          </a:xfrm>
+          <a:prstGeom prst="rect">
+            <a:avLst/>
+          </a:prstGeom>
+        </p:spPr>
+      </p:pic>
+      <p:sp>
+        <p:nvSpPr>
+          <p:cNvPr id="18" name="TextBox Header"/>
+          <p:cNvSpPr txBox="1"/>
+          <p:nvPr/>
+        </p:nvSpPr>
+        <p:spPr>
+          <a:xfrm>
+            <a:off x="1645919" y="4544569"/>
+            <a:ext cx="4038447" cy="365760"/>
+          </a:xfrm>
+          <a:prstGeom prst="rect">
+            <a:avLst/>
+          </a:prstGeom>
+          <a:noFill/>
+        </p:spPr>
+        <p:txBody>
+          <a:bodyPr wrap="square" lIns="0" tIns="0" rIns="0" bIns="0" anchor="t">
+            <a:spAutoFit/>
+          </a:bodyPr>
+          <a:lstStyle/>
+          <a:p>
+            <a:pPr algn="l"/>
+            <a:r>
+              <a:rPr sz="1550" b="1" i="0">
+                <a:solidFill>
+                  <a:srgbClr val="FFFFFF"/>
+                </a:solidFill>
+                <a:latin typeface="Cambria"/>
+              </a:rPr>
+              <a:t>Apple Watch</a:t>
+            </a:r>
+          </a:p>
+        </p:txBody>
+      </p:sp>
+      <p:sp>
+        <p:nvSpPr>
+          <p:cNvPr id="19" name="TextBox Body"/>
+          <p:cNvSpPr txBox="1"/>
+          <p:nvPr/>
+        </p:nvSpPr>
+        <p:spPr>
+          <a:xfrm>
+            <a:off x="1645919" y="4910329"/>
+            <a:ext cx="4038447" cy="1417320"/>
+          </a:xfrm>
+          <a:prstGeom prst="rect">
+            <a:avLst/>
+          </a:prstGeom>
+          <a:noFill/>
+        </p:spPr>
+        <p:txBody>
+          <a:bodyPr wrap="square" lIns="0" tIns="0" rIns="0" bIns="0" anchor="t">
+            <a:spAutoFit/>
+          </a:bodyPr>
+          <a:lstStyle/>
+          <a:p>
+            <a:pPr algn="l">
+              <a:lnSpc>
+                <a:spcPct val="118000"/>
+              </a:lnSpc>
+            </a:pPr>
+            <a:r>
+              <a:rPr sz="1200" b="0" i="0">
+                <a:solidFill>
+                  <a:srgbClr val="B9C6CE"/>
+                </a:solidFill>
+                <a:latin typeface="Calibri"/>
+              </a:rPr>
+              <a:t>Alarms sync device-to-device via WatchConnectivity and live in a local App Group on your Watch — never synced to iCloud from the Watch.</a:t>
+            </a:r>
+          </a:p>
+        </p:txBody>
+      </p:sp>
+      <p:sp>
+        <p:nvSpPr>
+          <p:cNvPr id="20" name="Rounded Rectangle"/>
+          <p:cNvSpPr/>
+          <p:nvPr/>
+        </p:nvSpPr>
+        <p:spPr>
+          <a:xfrm>
+            <a:off x="6278727" y="4343400"/>
+            <a:ext cx="5364327" cy="2148840"/>
+          </a:xfrm>
+          <a:prstGeom prst="roundRect">
+            <a:avLst>
+              <a:gd name="adj" fmla="val 7000"/>
+            </a:avLst>
+          </a:prstGeom>
+          <a:solidFill>
+            <a:srgbClr val="24455F"/>
+          </a:solidFill>
+          <a:ln>
+            <a:noFill/>
+          </a:ln>
+          <a:effectLst/>
+        </p:spPr>
+        <p:style>
+          <a:lnRef idx="1">
+            <a:schemeClr val="accent1"/>
+          </a:lnRef>
+          <a:fillRef idx="3">
+            <a:schemeClr val="accent1"/>
+          </a:fillRef>
+          <a:effectRef idx="2">
+            <a:schemeClr val="accent1"/>
+          </a:effectRef>
+          <a:fontRef idx="minor">
+            <a:schemeClr val="lt1"/>
+          </a:fontRef>
+        </p:style>
+        <p:txBody>
+          <a:bodyPr rtlCol="0" anchor="ctr"/>
+          <a:lstStyle/>
+          <a:p>
+            <a:pPr algn="ctr"/>
+            <a:endParaRPr/>
+          </a:p>
+        </p:txBody>
+      </p:sp>
+      <p:sp>
+        <p:nvSpPr>
+          <p:cNvPr id="21" name="Oval"/>
+          <p:cNvSpPr/>
+          <p:nvPr/>
+        </p:nvSpPr>
+        <p:spPr>
+          <a:xfrm>
+            <a:off x="6553047" y="5088637"/>
+            <a:ext cx="658368" cy="658368"/>
+          </a:xfrm>
+          <a:prstGeom prst="ellipse">
+            <a:avLst/>
+          </a:prstGeom>
+          <a:solidFill>
+            <a:srgbClr val="0F2836"/>
+          </a:solidFill>
+          <a:ln>
+            <a:noFill/>
+          </a:ln>
+          <a:effectLst/>
+        </p:spPr>
+        <p:style>
+          <a:lnRef idx="1">
+            <a:schemeClr val="accent1"/>
+          </a:lnRef>
+          <a:fillRef idx="3">
+            <a:schemeClr val="accent1"/>
+          </a:fillRef>
+          <a:effectRef idx="2">
+            <a:schemeClr val="accent1"/>
+          </a:effectRef>
+          <a:fontRef idx="minor">
+            <a:schemeClr val="lt1"/>
+          </a:fontRef>
+        </p:style>
+        <p:txBody>
+          <a:bodyPr rtlCol="0" anchor="ctr"/>
+          <a:lstStyle/>
+          <a:p>
+            <a:pPr algn="ctr"/>
+            <a:endParaRPr/>
+          </a:p>
+        </p:txBody>
+      </p:sp>
+      <p:pic>
+        <p:nvPicPr>
+          <p:cNvPr id="22" name="Picture" descr="privacy_icon.png"/>
+          <p:cNvPicPr>
+            <a:picLocks noChangeAspect="1"/>
+          </p:cNvPicPr>
+          <p:nvPr/>
+        </p:nvPicPr>
+        <p:blipFill>
+          <a:blip r:embed="rId5"/>
+          <a:stretch>
+            <a:fillRect/>
+          </a:stretch>
+        </p:blipFill>
+        <p:spPr>
+          <a:xfrm>
+            <a:off x="6711055" y="5246645"/>
+            <a:ext cx="342351" cy="342351"/>
+          </a:xfrm>
+          <a:prstGeom prst="rect">
+            <a:avLst/>
+          </a:prstGeom>
+        </p:spPr>
+      </p:pic>
+      <p:sp>
+        <p:nvSpPr>
+          <p:cNvPr id="23" name="TextBox Header"/>
+          <p:cNvSpPr txBox="1"/>
+          <p:nvPr/>
+        </p:nvSpPr>
+        <p:spPr>
+          <a:xfrm>
+            <a:off x="7376006" y="4544569"/>
+            <a:ext cx="4038447" cy="365760"/>
+          </a:xfrm>
+          <a:prstGeom prst="rect">
+            <a:avLst/>
+          </a:prstGeom>
+          <a:noFill/>
+        </p:spPr>
+        <p:txBody>
+          <a:bodyPr wrap="square" lIns="0" tIns="0" rIns="0" bIns="0" anchor="t">
+            <a:spAutoFit/>
+          </a:bodyPr>
+          <a:lstStyle/>
+          <a:p>
+            <a:pPr algn="l"/>
+            <a:r>
+              <a:rPr sz="1550" b="1" i="0">
+                <a:solidFill>
+                  <a:srgbClr val="FFFFFF"/>
+                </a:solidFill>
+                <a:latin typeface="Cambria"/>
+              </a:rPr>
+              <a:t>Diagnostics</a:t>
+            </a:r>
+          </a:p>
+        </p:txBody>
+      </p:sp>
+      <p:sp>
+        <p:nvSpPr>
+          <p:cNvPr id="24" name="TextBox Body"/>
+          <p:cNvSpPr txBox="1"/>
+          <p:nvPr/>
+        </p:nvSpPr>
+        <p:spPr>
+          <a:xfrm>
+            <a:off x="7376006" y="4910329"/>
+            <a:ext cx="4038447" cy="1417320"/>
+          </a:xfrm>
+          <a:prstGeom prst="rect">
+            <a:avLst/>
+          </a:prstGeom>
+          <a:noFill/>
+        </p:spPr>
+        <p:txBody>
+          <a:bodyPr wrap="square" lIns="0" tIns="0" rIns="0" bIns="0" anchor="t">
+            <a:spAutoFit/>
+          </a:bodyPr>
+          <a:lstStyle/>
+          <a:p>
+            <a:pPr algn="l">
+              <a:lnSpc>
+                <a:spcPct val="118000"/>
+              </a:lnSpc>
+            </a:pPr>
+            <a:r>
+              <a:rPr sz="1200" b="0" i="0">
+                <a:solidFill>
+                  <a:srgbClr val="B9C6CE"/>
+                </a:solidFill>
+                <a:latin typeface="Calibri"/>
+              </a:rPr>
+              <a:t>Anonymous crash reports via Firebase Crashlytics help me fix bugs — never used for ads, tracking, or profiling.</a:t>
+            </a:r>
+          </a:p>
+        </p:txBody>
+      </p:sp>
+      <p:sp>
+        <p:nvSpPr>
+          <p:cNvPr id="25" name="Rounded Rectangle Badge"/>
+          <p:cNvSpPr/>
+          <p:nvPr/>
+        </p:nvSpPr>
+        <p:spPr>
+          <a:xfrm>
+            <a:off x="11323015" y="6025896"/>
+            <a:ext cx="603504" cy="603504"/>
+          </a:xfrm>
+          <a:prstGeom prst="roundRect">
+            <a:avLst>
+              <a:gd name="adj" fmla="val 32000"/>
+            </a:avLst>
+          </a:prstGeom>
+          <a:solidFill>
+            <a:srgbClr val="FFFFFF"/>
+          </a:solidFill>
+          <a:ln>
+            <a:noFill/>
+          </a:ln>
+          <a:effectLst>
+            <a:outerShdw blurRad="90000" dist="30000" dir="5400000" rotWithShape="0">
+              <a:srgbClr val="0F2836">
+                <a:alpha val="22000"/>
+              </a:srgbClr>
+            </a:outerShdw>
+          </a:effectLst>
+        </p:spPr>
+        <p:style>
+          <a:lnRef idx="1">
+            <a:schemeClr val="accent1"/>
+          </a:lnRef>
+          <a:fillRef idx="3">
+            <a:schemeClr val="accent1"/>
+          </a:fillRef>
+          <a:effectRef idx="2">
+            <a:schemeClr val="accent1"/>
+          </a:effectRef>
+          <a:fontRef idx="minor">
+            <a:schemeClr val="lt1"/>
+          </a:fontRef>
+        </p:style>
+        <p:txBody>
+          <a:bodyPr rtlCol="0" anchor="ctr"/>
+          <a:lstStyle/>
+          <a:p>
+            <a:pPr algn="ctr"/>
+            <a:endParaRPr/>
+          </a:p>
+        </p:txBody>
+      </p:sp>
+      <p:pic>
+        <p:nvPicPr>
+          <p:cNvPr id="26" name="Picture Logo" descr="app_icon_rounded.png"/>
+          <p:cNvPicPr>
+            <a:picLocks noChangeAspect="1"/>
+          </p:cNvPicPr>
+          <p:nvPr/>
+        </p:nvPicPr>
+        <p:blipFill>
+          <a:blip r:embed="rId6"/>
+          <a:stretch>
+            <a:fillRect/>
+          </a:stretch>
+        </p:blipFill>
+        <p:spPr>
+          <a:xfrm>
+            <a:off x="11368735" y="6071616"/>
+            <a:ext cx="512064" cy="512064"/>
+          </a:xfrm>
+          <a:prstGeom prst="rect">
+            <a:avLst/>
+          </a:prstGeom>
+        </p:spPr>
+      </p:pic>
+    </p:spTree>
+  </p:cSld>
+  <p:clrMapOvr>
+    <a:masterClrMapping/>
+  </p:clrMapOvr>
+</p:sld>
+</file>
+
+<file path=ppt/slides/slide17.xml><?xml version="1.0" encoding="utf-8"?>
 <p:sld xmlns:a="http://schemas.openxmlformats.org/drawingml/2006/main" xmlns:r="http://schemas.openxmlformats.org/officeDocument/2006/relationships" xmlns:p="http://schemas.openxmlformats.org/presentationml/2006/main">
   <p:cSld>
     <p:bg>
@@ -7659,7 +8604,7 @@
 </p:sld>
 </file>
 
-<file path=ppt/slides/slide17.xml><?xml version="1.0" encoding="utf-8"?>
+<file path=ppt/slides/slide18.xml><?xml version="1.0" encoding="utf-8"?>
 <p:sld xmlns:a="http://schemas.openxmlformats.org/drawingml/2006/main" xmlns:r="http://schemas.openxmlformats.org/officeDocument/2006/relationships" xmlns:p="http://schemas.openxmlformats.org/presentationml/2006/main">
   <p:cSld>
     <p:bg>
@@ -8676,7 +9621,7 @@
 </p:sld>
 </file>
 
-<file path=ppt/slides/slide18.xml><?xml version="1.0" encoding="utf-8"?>
+<file path=ppt/slides/slide19.xml><?xml version="1.0" encoding="utf-8"?>
 <p:sld xmlns:a="http://schemas.openxmlformats.org/drawingml/2006/main" xmlns:r="http://schemas.openxmlformats.org/officeDocument/2006/relationships" xmlns:p="http://schemas.openxmlformats.org/presentationml/2006/main">
   <p:cSld>
     <p:bg>

</xml_diff>

<commit_message>
1) Align help to actual code base feature set 2) Align Sound roster in code base in help and provide translation keys 3) remove thrid party crash reporting, go with native now. 4) align privacy statement across all docments that call for statements
</commit_message>
<xml_diff>
--- a/docs/GeoNap Presentations/GeoNap_Marketing_Deck.pptx
+++ b/docs/GeoNap Presentations/GeoNap_Marketing_Deck.pptx
@@ -7947,7 +7947,7 @@
                 </a:solidFill>
                 <a:latin typeface="Calibri"/>
               </a:rPr>
-              <a:t>Anonymous crash reports via Firebase Crashlytics help me fix bugs — never used for ads, tracking, or profiling.</a:t>
+              <a:t>Crash and error logging happens entirely on-device via Apple’s own OSLog — no third-party crash SDK, nothing ever leaves your device.</a:t>
             </a:r>
           </a:p>
         </p:txBody>
@@ -11661,7 +11661,7 @@
                 </a:solidFill>
                 <a:latin typeface="Calibri"/>
               </a:rPr>
-              <a:t>Up to 20 active alarms at once — plenty for a daily commute plus every stop on a trip.</a:t>
+              <a:t>Up to 20 active alarms at once on paid tiers — plenty for a daily commute plus every stop on a trip. Free tier includes one active alarm.</a:t>
             </a:r>
           </a:p>
         </p:txBody>

</xml_diff>

<commit_message>
1) Address teir inconsistent labeling, change from/to Free → Standard -> Silver → Gold /Free → Silver → Gold → Platinum
</commit_message>
<xml_diff>
--- a/docs/GeoNap Presentations/GeoNap_Marketing_Deck.pptx
+++ b/docs/GeoNap Presentations/GeoNap_Marketing_Deck.pptx
@@ -320,7 +320,7 @@
           <a:p>
             <a:fld id="{5BCAD085-E8A6-8845-BD4E-CB4CCA059FC4}" type="datetimeFigureOut">
               <a:rPr lang="en-US" smtClean="0"/>
-              <a:t>7/11/26</a:t>
+              <a:t>7/12/26</a:t>
             </a:fld>
             <a:endParaRPr lang="en-US"/>
           </a:p>
@@ -488,7 +488,7 @@
           <a:p>
             <a:fld id="{5BCAD085-E8A6-8845-BD4E-CB4CCA059FC4}" type="datetimeFigureOut">
               <a:rPr lang="en-US" smtClean="0"/>
-              <a:t>7/11/26</a:t>
+              <a:t>7/12/26</a:t>
             </a:fld>
             <a:endParaRPr lang="en-US"/>
           </a:p>
@@ -666,7 +666,7 @@
           <a:p>
             <a:fld id="{5BCAD085-E8A6-8845-BD4E-CB4CCA059FC4}" type="datetimeFigureOut">
               <a:rPr lang="en-US" smtClean="0"/>
-              <a:t>7/11/26</a:t>
+              <a:t>7/12/26</a:t>
             </a:fld>
             <a:endParaRPr lang="en-US"/>
           </a:p>
@@ -834,7 +834,7 @@
           <a:p>
             <a:fld id="{5BCAD085-E8A6-8845-BD4E-CB4CCA059FC4}" type="datetimeFigureOut">
               <a:rPr lang="en-US" smtClean="0"/>
-              <a:t>7/11/26</a:t>
+              <a:t>7/12/26</a:t>
             </a:fld>
             <a:endParaRPr lang="en-US"/>
           </a:p>
@@ -1079,7 +1079,7 @@
           <a:p>
             <a:fld id="{5BCAD085-E8A6-8845-BD4E-CB4CCA059FC4}" type="datetimeFigureOut">
               <a:rPr lang="en-US" smtClean="0"/>
-              <a:t>7/11/26</a:t>
+              <a:t>7/12/26</a:t>
             </a:fld>
             <a:endParaRPr lang="en-US"/>
           </a:p>
@@ -1364,7 +1364,7 @@
           <a:p>
             <a:fld id="{5BCAD085-E8A6-8845-BD4E-CB4CCA059FC4}" type="datetimeFigureOut">
               <a:rPr lang="en-US" smtClean="0"/>
-              <a:t>7/11/26</a:t>
+              <a:t>7/12/26</a:t>
             </a:fld>
             <a:endParaRPr lang="en-US"/>
           </a:p>
@@ -1783,7 +1783,7 @@
           <a:p>
             <a:fld id="{5BCAD085-E8A6-8845-BD4E-CB4CCA059FC4}" type="datetimeFigureOut">
               <a:rPr lang="en-US" smtClean="0"/>
-              <a:t>7/11/26</a:t>
+              <a:t>7/12/26</a:t>
             </a:fld>
             <a:endParaRPr lang="en-US"/>
           </a:p>
@@ -1900,7 +1900,7 @@
           <a:p>
             <a:fld id="{5BCAD085-E8A6-8845-BD4E-CB4CCA059FC4}" type="datetimeFigureOut">
               <a:rPr lang="en-US" smtClean="0"/>
-              <a:t>7/11/26</a:t>
+              <a:t>7/12/26</a:t>
             </a:fld>
             <a:endParaRPr lang="en-US"/>
           </a:p>
@@ -1995,7 +1995,7 @@
           <a:p>
             <a:fld id="{5BCAD085-E8A6-8845-BD4E-CB4CCA059FC4}" type="datetimeFigureOut">
               <a:rPr lang="en-US" smtClean="0"/>
-              <a:t>7/11/26</a:t>
+              <a:t>7/12/26</a:t>
             </a:fld>
             <a:endParaRPr lang="en-US"/>
           </a:p>
@@ -2270,7 +2270,7 @@
           <a:p>
             <a:fld id="{5BCAD085-E8A6-8845-BD4E-CB4CCA059FC4}" type="datetimeFigureOut">
               <a:rPr lang="en-US" smtClean="0"/>
-              <a:t>7/11/26</a:t>
+              <a:t>7/12/26</a:t>
             </a:fld>
             <a:endParaRPr lang="en-US"/>
           </a:p>
@@ -2522,7 +2522,7 @@
           <a:p>
             <a:fld id="{5BCAD085-E8A6-8845-BD4E-CB4CCA059FC4}" type="datetimeFigureOut">
               <a:rPr lang="en-US" smtClean="0"/>
-              <a:t>7/11/26</a:t>
+              <a:t>7/12/26</a:t>
             </a:fld>
             <a:endParaRPr lang="en-US"/>
           </a:p>
@@ -2733,7 +2733,7 @@
           <a:p>
             <a:fld id="{5BCAD085-E8A6-8845-BD4E-CB4CCA059FC4}" type="datetimeFigureOut">
               <a:rPr lang="en-US" smtClean="0"/>
-              <a:t>7/11/26</a:t>
+              <a:t>7/12/26</a:t>
             </a:fld>
             <a:endParaRPr lang="en-US"/>
           </a:p>
@@ -8712,7 +8712,7 @@
           <p:nvPr>
             <p:extLst>
               <p:ext uri="{D42A27DB-BD31-4B8C-83A1-F6EECF244321}">
-                <p14:modId xmlns:p14="http://schemas.microsoft.com/office/powerpoint/2010/main" val="914684238"/>
+                <p14:modId xmlns:p14="http://schemas.microsoft.com/office/powerpoint/2010/main" val="1610082017"/>
               </p:ext>
             </p:extLst>
           </p:nvPr>
@@ -8952,8 +8952,10 @@
                         </a:defRPr>
                       </a:pPr>
                       <a:r>
-                        <a:t>Standard</a:t>
+                        <a:rPr lang="en-US"/>
+                        <a:t>Silver</a:t>
                       </a:r>
+                      <a:endParaRPr dirty="0"/>
                     </a:p>
                     <a:p>
                       <a:pPr>
@@ -8965,6 +8967,7 @@
                         </a:defRPr>
                       </a:pPr>
                       <a:r>
+                        <a:rPr dirty="0"/>
                         <a:t>$2.99 / year</a:t>
                       </a:r>
                     </a:p>
@@ -9123,8 +9126,10 @@
                         </a:defRPr>
                       </a:pPr>
                       <a:r>
-                        <a:t>Silver</a:t>
+                        <a:rPr lang="en-US" dirty="0"/>
+                        <a:t>Gold</a:t>
                       </a:r>
+                      <a:endParaRPr dirty="0"/>
                     </a:p>
                     <a:p>
                       <a:pPr>
@@ -9136,6 +9141,7 @@
                         </a:defRPr>
                       </a:pPr>
                       <a:r>
+                        <a:rPr dirty="0"/>
                         <a:t>$6.99 / year</a:t>
                       </a:r>
                     </a:p>
@@ -9270,9 +9276,17 @@
                         </a:defRPr>
                       </a:pPr>
                       <a:r>
-                        <a:rPr dirty="0"/>
-                        <a:t>Gold</a:t>
+                        <a:rPr lang="en-US" sz="1400" b="1" kern="1200" dirty="0">
+                          <a:solidFill>
+                            <a:schemeClr val="dk1"/>
+                          </a:solidFill>
+                          <a:latin typeface="+mn-lt"/>
+                          <a:ea typeface="+mn-ea"/>
+                          <a:cs typeface="+mn-cs"/>
+                        </a:rPr>
+                        <a:t>Platinum</a:t>
                       </a:r>
+                      <a:endParaRPr dirty="0"/>
                     </a:p>
                     <a:p>
                       <a:pPr>

</xml_diff>

<commit_message>
1) Update support emails and privacy statment to align with creation of mba-labs website which will host this a future products while provide some secuirity and isolation from personal emails, etc. 2) Enaure alarms, per-day, selection is only enabled when user had enabled "Repeat" 3) Make updates to Marketing deck to correct pricing tiers
</commit_message>
<xml_diff>
--- a/docs/GeoNap Presentations/GeoNap_Marketing_Deck.pptx
+++ b/docs/GeoNap Presentations/GeoNap_Marketing_Deck.pptx
@@ -320,7 +320,7 @@
           <a:p>
             <a:fld id="{5BCAD085-E8A6-8845-BD4E-CB4CCA059FC4}" type="datetimeFigureOut">
               <a:rPr lang="en-US" smtClean="0"/>
-              <a:t>7/12/26</a:t>
+              <a:t>8/6/26</a:t>
             </a:fld>
             <a:endParaRPr lang="en-US"/>
           </a:p>
@@ -488,7 +488,7 @@
           <a:p>
             <a:fld id="{5BCAD085-E8A6-8845-BD4E-CB4CCA059FC4}" type="datetimeFigureOut">
               <a:rPr lang="en-US" smtClean="0"/>
-              <a:t>7/12/26</a:t>
+              <a:t>8/6/26</a:t>
             </a:fld>
             <a:endParaRPr lang="en-US"/>
           </a:p>
@@ -666,7 +666,7 @@
           <a:p>
             <a:fld id="{5BCAD085-E8A6-8845-BD4E-CB4CCA059FC4}" type="datetimeFigureOut">
               <a:rPr lang="en-US" smtClean="0"/>
-              <a:t>7/12/26</a:t>
+              <a:t>8/6/26</a:t>
             </a:fld>
             <a:endParaRPr lang="en-US"/>
           </a:p>
@@ -834,7 +834,7 @@
           <a:p>
             <a:fld id="{5BCAD085-E8A6-8845-BD4E-CB4CCA059FC4}" type="datetimeFigureOut">
               <a:rPr lang="en-US" smtClean="0"/>
-              <a:t>7/12/26</a:t>
+              <a:t>8/6/26</a:t>
             </a:fld>
             <a:endParaRPr lang="en-US"/>
           </a:p>
@@ -1079,7 +1079,7 @@
           <a:p>
             <a:fld id="{5BCAD085-E8A6-8845-BD4E-CB4CCA059FC4}" type="datetimeFigureOut">
               <a:rPr lang="en-US" smtClean="0"/>
-              <a:t>7/12/26</a:t>
+              <a:t>8/6/26</a:t>
             </a:fld>
             <a:endParaRPr lang="en-US"/>
           </a:p>
@@ -1364,7 +1364,7 @@
           <a:p>
             <a:fld id="{5BCAD085-E8A6-8845-BD4E-CB4CCA059FC4}" type="datetimeFigureOut">
               <a:rPr lang="en-US" smtClean="0"/>
-              <a:t>7/12/26</a:t>
+              <a:t>8/6/26</a:t>
             </a:fld>
             <a:endParaRPr lang="en-US"/>
           </a:p>
@@ -1783,7 +1783,7 @@
           <a:p>
             <a:fld id="{5BCAD085-E8A6-8845-BD4E-CB4CCA059FC4}" type="datetimeFigureOut">
               <a:rPr lang="en-US" smtClean="0"/>
-              <a:t>7/12/26</a:t>
+              <a:t>8/6/26</a:t>
             </a:fld>
             <a:endParaRPr lang="en-US"/>
           </a:p>
@@ -1900,7 +1900,7 @@
           <a:p>
             <a:fld id="{5BCAD085-E8A6-8845-BD4E-CB4CCA059FC4}" type="datetimeFigureOut">
               <a:rPr lang="en-US" smtClean="0"/>
-              <a:t>7/12/26</a:t>
+              <a:t>8/6/26</a:t>
             </a:fld>
             <a:endParaRPr lang="en-US"/>
           </a:p>
@@ -1995,7 +1995,7 @@
           <a:p>
             <a:fld id="{5BCAD085-E8A6-8845-BD4E-CB4CCA059FC4}" type="datetimeFigureOut">
               <a:rPr lang="en-US" smtClean="0"/>
-              <a:t>7/12/26</a:t>
+              <a:t>8/6/26</a:t>
             </a:fld>
             <a:endParaRPr lang="en-US"/>
           </a:p>
@@ -2270,7 +2270,7 @@
           <a:p>
             <a:fld id="{5BCAD085-E8A6-8845-BD4E-CB4CCA059FC4}" type="datetimeFigureOut">
               <a:rPr lang="en-US" smtClean="0"/>
-              <a:t>7/12/26</a:t>
+              <a:t>8/6/26</a:t>
             </a:fld>
             <a:endParaRPr lang="en-US"/>
           </a:p>
@@ -2522,7 +2522,7 @@
           <a:p>
             <a:fld id="{5BCAD085-E8A6-8845-BD4E-CB4CCA059FC4}" type="datetimeFigureOut">
               <a:rPr lang="en-US" smtClean="0"/>
-              <a:t>7/12/26</a:t>
+              <a:t>8/6/26</a:t>
             </a:fld>
             <a:endParaRPr lang="en-US"/>
           </a:p>
@@ -2733,7 +2733,7 @@
           <a:p>
             <a:fld id="{5BCAD085-E8A6-8845-BD4E-CB4CCA059FC4}" type="datetimeFigureOut">
               <a:rPr lang="en-US" smtClean="0"/>
-              <a:t>7/12/26</a:t>
+              <a:t>8/6/26</a:t>
             </a:fld>
             <a:endParaRPr lang="en-US"/>
           </a:p>
@@ -8142,11 +8142,17 @@
           <p:cNvGraphicFramePr>
             <a:graphicFrameLocks noGrp="1"/>
           </p:cNvGraphicFramePr>
-          <p:nvPr/>
+          <p:nvPr>
+            <p:extLst>
+              <p:ext uri="{D42A27DB-BD31-4B8C-83A1-F6EECF244321}">
+                <p14:modId xmlns:p14="http://schemas.microsoft.com/office/powerpoint/2010/main" val="1502356154"/>
+              </p:ext>
+            </p:extLst>
+          </p:nvPr>
         </p:nvGraphicFramePr>
         <p:xfrm>
-          <a:off x="548640" y="1874519"/>
-          <a:ext cx="11091672" cy="4160520"/>
+          <a:off x="548640" y="1298446"/>
+          <a:ext cx="11091672" cy="5157216"/>
         </p:xfrm>
         <a:graphic>
           <a:graphicData uri="http://schemas.openxmlformats.org/drawingml/2006/table">
@@ -8170,7 +8176,7 @@
                   </a:extLst>
                 </a:gridCol>
               </a:tblGrid>
-              <a:tr h="832104">
+              <a:tr h="859536">
                 <a:tc>
                   <a:txBody>
                     <a:bodyPr/>
@@ -8225,7 +8231,7 @@
                   </a:ext>
                 </a:extLst>
               </a:tr>
-              <a:tr h="832104">
+              <a:tr h="859536">
                 <a:tc>
                   <a:txBody>
                     <a:bodyPr/>
@@ -8280,7 +8286,7 @@
                   </a:ext>
                 </a:extLst>
               </a:tr>
-              <a:tr h="832104">
+              <a:tr h="859536">
                 <a:tc>
                   <a:txBody>
                     <a:bodyPr/>
@@ -8335,7 +8341,7 @@
                   </a:ext>
                 </a:extLst>
               </a:tr>
-              <a:tr h="832104">
+              <a:tr h="859536">
                 <a:tc>
                   <a:txBody>
                     <a:bodyPr/>
@@ -8374,6 +8380,7 @@
                         </a:defRPr>
                       </a:pPr>
                       <a:r>
+                        <a:rPr dirty="0"/>
                         <a:t>watchOS 26.0 or later (companion features)</a:t>
                       </a:r>
                     </a:p>
@@ -8390,7 +8397,98 @@
                   </a:ext>
                 </a:extLst>
               </a:tr>
-              <a:tr h="832104">
+              <a:tr h="859536">
+                <a:tc>
+                  <a:txBody>
+                    <a:bodyPr/>
+                    <a:lstStyle/>
+                    <a:p>
+                      <a:pPr marL="0" algn="l" defTabSz="457200" rtl="0" eaLnBrk="1" latinLnBrk="0" hangingPunct="1">
+                        <a:defRPr sz="1250" b="1">
+                          <a:solidFill>
+                            <a:srgbClr val="17303F"/>
+                          </a:solidFill>
+                          <a:latin typeface="Calibri"/>
+                        </a:defRPr>
+                      </a:pPr>
+                      <a:r>
+                        <a:rPr lang="en-US" sz="1250" b="1" kern="1200" dirty="0">
+                          <a:solidFill>
+                            <a:srgbClr val="17303F"/>
+                          </a:solidFill>
+                          <a:latin typeface="Calibri"/>
+                          <a:ea typeface="+mn-ea"/>
+                          <a:cs typeface="+mn-cs"/>
+                        </a:rPr>
+                        <a:t>Car Play / Apple Shortcuts</a:t>
+                      </a:r>
+                      <a:endParaRPr sz="1250" b="1" kern="1200" dirty="0">
+                        <a:solidFill>
+                          <a:srgbClr val="17303F"/>
+                        </a:solidFill>
+                        <a:latin typeface="Calibri"/>
+                        <a:ea typeface="+mn-ea"/>
+                        <a:cs typeface="+mn-cs"/>
+                      </a:endParaRPr>
+                    </a:p>
+                  </a:txBody>
+                  <a:tcPr marL="109728" anchor="ctr">
+                    <a:solidFill>
+                      <a:schemeClr val="bg1">
+                        <a:lumMod val="95000"/>
+                      </a:schemeClr>
+                    </a:solidFill>
+                  </a:tcPr>
+                </a:tc>
+                <a:tc>
+                  <a:txBody>
+                    <a:bodyPr/>
+                    <a:lstStyle/>
+                    <a:p>
+                      <a:pPr marL="0" algn="l" defTabSz="457200" rtl="0" eaLnBrk="1" latinLnBrk="0" hangingPunct="1">
+                        <a:defRPr sz="1250" b="1">
+                          <a:solidFill>
+                            <a:srgbClr val="17303F"/>
+                          </a:solidFill>
+                          <a:latin typeface="Calibri"/>
+                        </a:defRPr>
+                      </a:pPr>
+                      <a:r>
+                        <a:rPr lang="en-US" sz="1250" b="1" kern="1200" dirty="0">
+                          <a:solidFill>
+                            <a:srgbClr val="17303F"/>
+                          </a:solidFill>
+                          <a:latin typeface="Calibri"/>
+                          <a:ea typeface="+mn-ea"/>
+                          <a:cs typeface="+mn-cs"/>
+                        </a:rPr>
+                        <a:t>Supported</a:t>
+                      </a:r>
+                      <a:endParaRPr sz="1250" b="1" kern="1200" dirty="0">
+                        <a:solidFill>
+                          <a:srgbClr val="17303F"/>
+                        </a:solidFill>
+                        <a:latin typeface="Calibri"/>
+                        <a:ea typeface="+mn-ea"/>
+                        <a:cs typeface="+mn-cs"/>
+                      </a:endParaRPr>
+                    </a:p>
+                  </a:txBody>
+                  <a:tcPr marL="109728" anchor="ctr">
+                    <a:solidFill>
+                      <a:schemeClr val="bg1">
+                        <a:lumMod val="95000"/>
+                      </a:schemeClr>
+                    </a:solidFill>
+                  </a:tcPr>
+                </a:tc>
+                <a:extLst>
+                  <a:ext uri="{0D108BD9-81ED-4DB2-BD59-A6C34878D82A}">
+                    <a16:rowId xmlns:a16="http://schemas.microsoft.com/office/drawing/2014/main" val="3441994490"/>
+                  </a:ext>
+                </a:extLst>
+              </a:tr>
+              <a:tr h="859536">
                 <a:tc>
                   <a:txBody>
                     <a:bodyPr/>
@@ -8405,13 +8503,14 @@
                         </a:defRPr>
                       </a:pPr>
                       <a:r>
+                        <a:rPr dirty="0"/>
                         <a:t>Connectivity</a:t>
                       </a:r>
                     </a:p>
                   </a:txBody>
                   <a:tcPr marL="109728" anchor="ctr">
                     <a:solidFill>
-                      <a:srgbClr val="EFF2F5"/>
+                      <a:schemeClr val="bg1"/>
                     </a:solidFill>
                   </a:tcPr>
                 </a:tc>
@@ -8429,13 +8528,14 @@
                         </a:defRPr>
                       </a:pPr>
                       <a:r>
+                        <a:rPr dirty="0"/>
                         <a:t>Offline for standard alarms; internet needed only for transit feed downloads</a:t>
                       </a:r>
                     </a:p>
                   </a:txBody>
                   <a:tcPr marL="109728" anchor="ctr">
                     <a:solidFill>
-                      <a:srgbClr val="EFF2F5"/>
+                      <a:schemeClr val="bg1"/>
                     </a:solidFill>
                   </a:tcPr>
                 </a:tc>
@@ -8712,7 +8812,7 @@
           <p:nvPr>
             <p:extLst>
               <p:ext uri="{D42A27DB-BD31-4B8C-83A1-F6EECF244321}">
-                <p14:modId xmlns:p14="http://schemas.microsoft.com/office/powerpoint/2010/main" val="1610082017"/>
+                <p14:modId xmlns:p14="http://schemas.microsoft.com/office/powerpoint/2010/main" val="22816343"/>
               </p:ext>
             </p:extLst>
           </p:nvPr>
@@ -9170,7 +9270,25 @@
                           </a:solidFill>
                           <a:latin typeface="Calibri"/>
                         </a:rPr>
-                        <a:t>Everything in Standard, plus:</a:t>
+                        <a:t>Everything in </a:t>
+                      </a:r>
+                      <a:r>
+                        <a:rPr lang="en-US" sz="1050" b="1" i="1" dirty="0">
+                          <a:solidFill>
+                            <a:srgbClr val="5C7182"/>
+                          </a:solidFill>
+                          <a:latin typeface="Calibri"/>
+                        </a:rPr>
+                        <a:t>Silver</a:t>
+                      </a:r>
+                      <a:r>
+                        <a:rPr sz="1050" b="1" i="1" dirty="0">
+                          <a:solidFill>
+                            <a:srgbClr val="5C7182"/>
+                          </a:solidFill>
+                          <a:latin typeface="Calibri"/>
+                        </a:rPr>
+                        <a:t>, plus:</a:t>
                       </a:r>
                     </a:p>
                     <a:p>
@@ -9327,7 +9445,43 @@
                           </a:solidFill>
                           <a:latin typeface="Calibri"/>
                         </a:rPr>
-                        <a:t>Everything in Silver, plus:</a:t>
+                        <a:t>Everything </a:t>
+                      </a:r>
+                      <a:r>
+                        <a:rPr sz="1050" b="1" i="1">
+                          <a:solidFill>
+                            <a:srgbClr val="5C7182"/>
+                          </a:solidFill>
+                          <a:latin typeface="Calibri"/>
+                        </a:rPr>
+                        <a:t>in </a:t>
+                      </a:r>
+                      <a:r>
+                        <a:rPr lang="en-US" sz="1050" b="1" i="1">
+                          <a:solidFill>
+                            <a:srgbClr val="5C7182"/>
+                          </a:solidFill>
+                          <a:latin typeface="Calibri"/>
+                        </a:rPr>
+                        <a:t>Glod</a:t>
+                      </a:r>
+                      <a:r>
+                        <a:rPr sz="1050" b="1" i="1">
+                          <a:solidFill>
+                            <a:srgbClr val="5C7182"/>
+                          </a:solidFill>
+                          <a:latin typeface="Calibri"/>
+                        </a:rPr>
+                        <a:t>, </a:t>
+                      </a:r>
+                      <a:r>
+                        <a:rPr sz="1050" b="1" i="1" dirty="0">
+                          <a:solidFill>
+                            <a:srgbClr val="5C7182"/>
+                          </a:solidFill>
+                          <a:latin typeface="Calibri"/>
+                        </a:rPr>
+                        <a:t>plus:</a:t>
                       </a:r>
                     </a:p>
                     <a:p>

</xml_diff>